<commit_message>
docs: deck 15 slides (P6 Weather) + roteiro + kit + parte 2
</commit_message>
<xml_diff>
--- a/presentation/3M_TechCase_Presentation.pptx
+++ b/presentation/3M_TechCase_Presentation.pptx
@@ -17,6 +17,7 @@
     <p:sldId id="265" r:id="rId11"/>
     <p:sldId id="266" r:id="rId12"/>
     <p:sldId id="267" r:id="rId13"/>
+    <p:sldId id="270" r:id="rId21"/>
     <p:sldId id="268" r:id="rId14"/>
     <p:sldId id="269" r:id="rId15"/>
   </p:sldIdLst>
@@ -3410,7 +3411,7 @@
                 <a:ea typeface="Segoe UI" pitchFamily="34" charset="-122"/>
                 <a:cs typeface="Segoe UI" pitchFamily="34" charset="-120"/>
               </a:rPr>
-              <a:t>Now switching to the live report → </a:t>
+              <a:t xml:space="preserve">Now switching to the live report → </a:t>
             </a:r>
             <a:pPr indent="0" marL="0">
               <a:buNone/>
@@ -5703,7 +5704,7 @@
                 <a:ea typeface="Segoe UI Semibold" pitchFamily="34" charset="-122"/>
                 <a:cs typeface="Segoe UI Semibold" pitchFamily="34" charset="-120"/>
               </a:rPr>
-              <a:t>Fare plateau in 2024</a:t>
+              <a:t>Seasonal &amp; weather stress (NOAA)</a:t>
             </a:r>
             <a:endParaRPr lang="en-US" sz="1500" dirty="0"/>
           </a:p>
@@ -5781,7 +5782,7 @@
                 <a:ea typeface="Segoe UI" pitchFamily="34" charset="-122"/>
                 <a:cs typeface="Segoe UI" pitchFamily="34" charset="-120"/>
               </a:rPr>
-              <a:t>Growth via volume, not price — healthy</a:t>
+              <a:t>Capacity planning &amp; disruption readiness</a:t>
             </a:r>
             <a:endParaRPr lang="en-US" sz="1300" dirty="0"/>
           </a:p>
@@ -6200,7 +6201,7 @@
                 <a:ea typeface="Segoe UI" pitchFamily="34" charset="-122"/>
                 <a:cs typeface="Segoe UI" pitchFamily="34" charset="-120"/>
               </a:rPr>
-              <a:t>time-series model per zone/hour</a:t>
+              <a:t>time-series per zone/hour, weather-aware</a:t>
             </a:r>
             <a:endParaRPr lang="en-US" sz="1150" dirty="0"/>
           </a:p>
@@ -6590,6 +6591,638 @@
               <a:t>Nicolas Augusto  ·  github.com/Nicolas-arch/3m-techcase-nyc-tlc</a:t>
             </a:r>
             <a:endParaRPr lang="en-US" sz="1300" dirty="0"/>
+          </a:p>
+        </p:txBody>
+      </p:sp>
+    </p:spTree>
+  </p:cSld>
+  <p:clrMapOvr>
+    <a:masterClrMapping/>
+  </p:clrMapOvr>
+</p:sld>
+</file>
+
+<file path=ppt/slides/slide15.xml><?xml version="1.0" encoding="utf-8"?>
+<p:sld xmlns:a="http://schemas.openxmlformats.org/drawingml/2006/main" xmlns:r="http://schemas.openxmlformats.org/officeDocument/2006/relationships" xmlns:p="http://schemas.openxmlformats.org/presentationml/2006/main">
+  <p:cSld name="Slide 12">
+    <p:bg>
+      <p:bgPr>
+        <a:solidFill>
+          <a:srgbClr val="FFFFFF"/>
+        </a:solidFill>
+      </p:bgPr>
+    </p:bg>
+    <p:spTree>
+      <p:nvGrpSpPr>
+        <p:cNvPr id="1" name=""/>
+        <p:cNvGrpSpPr/>
+        <p:nvPr/>
+      </p:nvGrpSpPr>
+      <p:grpSpPr>
+        <a:xfrm>
+          <a:off x="0" y="0"/>
+          <a:ext cx="0" cy="0"/>
+          <a:chOff x="0" y="0"/>
+          <a:chExt cx="0" cy="0"/>
+        </a:xfrm>
+      </p:grpSpPr>
+      <p:sp>
+        <p:nvSpPr>
+          <p:cNvPr id="2" name="Text 0"/>
+          <p:cNvSpPr/>
+          <p:nvPr/>
+        </p:nvSpPr>
+        <p:spPr>
+          <a:xfrm>
+            <a:off x="548640" y="384048"/>
+            <a:ext cx="11064240" cy="274320"/>
+          </a:xfrm>
+          <a:prstGeom prst="rect">
+            <a:avLst/>
+          </a:prstGeom>
+          <a:noFill/>
+          <a:ln/>
+        </p:spPr>
+        <p:txBody>
+          <a:bodyPr wrap="square" lIns="0" tIns="0" rIns="0" bIns="0" rtlCol="0" anchor="ctr"/>
+          <a:lstStyle/>
+          <a:p>
+            <a:pPr indent="0" marL="0">
+              <a:buNone/>
+            </a:pPr>
+            <a:r>
+              <a:rPr lang="en-US" sz="1250" b="1" spc="200" kern="0" dirty="0">
+                <a:solidFill>
+                  <a:srgbClr val="2E75B6"/>
+                </a:solidFill>
+                <a:latin typeface="Segoe UI" pitchFamily="34" charset="0"/>
+                <a:ea typeface="Segoe UI" pitchFamily="34" charset="-122"/>
+                <a:cs typeface="Segoe UI" pitchFamily="34" charset="-120"/>
+              </a:rPr>
+              <a:t>06 · DASHBOARD</a:t>
+            </a:r>
+            <a:endParaRPr lang="en-US" sz="1250" dirty="0"/>
+          </a:p>
+        </p:txBody>
+      </p:sp>
+      <p:sp>
+        <p:nvSpPr>
+          <p:cNvPr id="3" name="Text 1"/>
+          <p:cNvSpPr/>
+          <p:nvPr/>
+        </p:nvSpPr>
+        <p:spPr>
+          <a:xfrm>
+            <a:off x="548640" y="640080"/>
+            <a:ext cx="11064240" cy="640080"/>
+          </a:xfrm>
+          <a:prstGeom prst="rect">
+            <a:avLst/>
+          </a:prstGeom>
+          <a:noFill/>
+          <a:ln/>
+        </p:spPr>
+        <p:txBody>
+          <a:bodyPr wrap="square" lIns="0" tIns="0" rIns="0" bIns="0" rtlCol="0" anchor="ctr"/>
+          <a:lstStyle/>
+          <a:p>
+            <a:pPr indent="0" marL="0">
+              <a:buNone/>
+            </a:pPr>
+            <a:r>
+              <a:rPr lang="en-US" sz="2900" b="1" dirty="0">
+                <a:solidFill>
+                  <a:srgbClr val="1F3864"/>
+                </a:solidFill>
+                <a:latin typeface="Segoe UI Semibold" pitchFamily="34" charset="0"/>
+                <a:ea typeface="Segoe UI Semibold" pitchFamily="34" charset="-122"/>
+                <a:cs typeface="Segoe UI Semibold" pitchFamily="34" charset="-120"/>
+              </a:rPr>
+              <a:t>Weather &amp; Operational Risk</a:t>
+            </a:r>
+            <a:endParaRPr lang="en-US" sz="2900" dirty="0"/>
+          </a:p>
+        </p:txBody>
+      </p:sp>
+      <p:sp>
+        <p:nvSpPr>
+          <p:cNvPr id="4" name="Shape 2"/>
+          <p:cNvSpPr/>
+          <p:nvPr/>
+        </p:nvSpPr>
+        <p:spPr>
+          <a:xfrm>
+            <a:off x="548640" y="1691640"/>
+            <a:ext cx="5486400" cy="4023360"/>
+          </a:xfrm>
+          <a:prstGeom prst="rect">
+            <a:avLst/>
+          </a:prstGeom>
+          <a:solidFill>
+            <a:srgbClr val="FFFFFF"/>
+          </a:solidFill>
+          <a:ln w="12700">
+            <a:solidFill>
+              <a:srgbClr val="E0E0E0"/>
+            </a:solidFill>
+            <a:prstDash val="solid"/>
+          </a:ln>
+          <a:effectLst>
+            <a:outerShdw sx="100000" sy="100000" kx="0" ky="0" algn="bl" rotWithShape="0" blurRad="101600" dist="38100" dir="8100000">
+              <a:srgbClr val="1F3864">
+                <a:alpha val="16000"/>
+              </a:srgbClr>
+            </a:outerShdw>
+          </a:effectLst>
+        </p:spPr>
+      </p:sp>
+      <p:sp>
+        <p:nvSpPr>
+          <p:cNvPr id="5" name="Shape 3"/>
+          <p:cNvSpPr/>
+          <p:nvPr/>
+        </p:nvSpPr>
+        <p:spPr>
+          <a:xfrm>
+            <a:off x="548640" y="1691640"/>
+            <a:ext cx="82296" cy="4023360"/>
+          </a:xfrm>
+          <a:prstGeom prst="rect">
+            <a:avLst/>
+          </a:prstGeom>
+          <a:solidFill>
+            <a:srgbClr val="2E75B6"/>
+          </a:solidFill>
+          <a:ln/>
+        </p:spPr>
+      </p:sp>
+      <p:sp>
+        <p:nvSpPr>
+          <p:cNvPr id="6" name="Text 4"/>
+          <p:cNvSpPr/>
+          <p:nvPr/>
+        </p:nvSpPr>
+        <p:spPr>
+          <a:xfrm>
+            <a:off x="777240" y="1837944"/>
+            <a:ext cx="5120640" cy="320040"/>
+          </a:xfrm>
+          <a:prstGeom prst="rect">
+            <a:avLst/>
+          </a:prstGeom>
+          <a:noFill/>
+          <a:ln/>
+        </p:spPr>
+        <p:txBody>
+          <a:bodyPr wrap="square" lIns="0" tIns="0" rIns="0" bIns="0" rtlCol="0" anchor="ctr"/>
+          <a:lstStyle/>
+          <a:p>
+            <a:pPr indent="0" marL="0">
+              <a:buNone/>
+            </a:pPr>
+            <a:r>
+              <a:rPr lang="en-US" sz="1450" b="1" dirty="0">
+                <a:solidFill>
+                  <a:srgbClr val="1F3864"/>
+                </a:solidFill>
+                <a:latin typeface="Segoe UI Semibold" pitchFamily="34" charset="0"/>
+                <a:ea typeface="Segoe UI Semibold" pitchFamily="34" charset="-122"/>
+                <a:cs typeface="Segoe UI Semibold" pitchFamily="34" charset="-120"/>
+              </a:rPr>
+              <a:t>Page 6 — Seasonality (NOAA)</a:t>
+            </a:r>
+            <a:endParaRPr lang="en-US" sz="1450" dirty="0"/>
+          </a:p>
+        </p:txBody>
+      </p:sp>
+      <p:sp>
+        <p:nvSpPr>
+          <p:cNvPr id="7" name="Text 5"/>
+          <p:cNvSpPr/>
+          <p:nvPr/>
+        </p:nvSpPr>
+        <p:spPr>
+          <a:xfrm>
+            <a:off x="777240" y="2203704"/>
+            <a:ext cx="5120640" cy="3383280"/>
+          </a:xfrm>
+          <a:prstGeom prst="rect">
+            <a:avLst/>
+          </a:prstGeom>
+          <a:noFill/>
+          <a:ln/>
+        </p:spPr>
+        <p:txBody>
+          <a:bodyPr wrap="square" lIns="0" tIns="0" rIns="0" bIns="0" rtlCol="0" anchor="t"/>
+          <a:lstStyle/>
+          <a:p>
+            <a:pPr indent="0" marL="0">
+              <a:buNone/>
+            </a:pPr>
+            <a:r>
+              <a:rPr lang="en-US" sz="1200" dirty="0">
+                <a:solidFill>
+                  <a:srgbClr val="595959"/>
+                </a:solidFill>
+                <a:latin typeface="Segoe UI" pitchFamily="34" charset="0"/>
+                <a:ea typeface="Segoe UI" pitchFamily="34" charset="-122"/>
+                <a:cs typeface="Segoe UI" pitchFamily="34" charset="-120"/>
+              </a:rPr>
+              <a:t>The 2nd external source: NOAA weather joined onto dim_date.</a:t>
+            </a:r>
+            <a:endParaRPr lang="en-US" sz="1200" dirty="0"/>
+          </a:p>
+          <a:p>
+            <a:pPr indent="0" marL="0">
+              <a:buNone/>
+            </a:pPr>
+            <a:endParaRPr lang="en-US" sz="1200" dirty="0"/>
+          </a:p>
+          <a:p>
+            <a:pPr indent="0" marL="0">
+              <a:buNone/>
+            </a:pPr>
+            <a:r>
+              <a:rPr lang="en-US" sz="1200" dirty="0">
+                <a:solidFill>
+                  <a:srgbClr val="595959"/>
+                </a:solidFill>
+                <a:latin typeface="Segoe UI" pitchFamily="34" charset="0"/>
+                <a:ea typeface="Segoe UI" pitchFamily="34" charset="-122"/>
+                <a:cs typeface="Segoe UI" pitchFamily="34" charset="-120"/>
+              </a:rPr>
+              <a:t>• Fall is the stress season: 2nd-highest volume (109k trips/day) with the worst lead time (18.46 min).</a:t>
+            </a:r>
+            <a:endParaRPr lang="en-US" sz="1200" dirty="0"/>
+          </a:p>
+          <a:p>
+            <a:pPr indent="0" marL="0">
+              <a:buNone/>
+            </a:pPr>
+            <a:endParaRPr lang="en-US" sz="1200" dirty="0"/>
+          </a:p>
+          <a:p>
+            <a:pPr indent="0" marL="0">
+              <a:buNone/>
+            </a:pPr>
+            <a:r>
+              <a:rPr lang="en-US" sz="1200" dirty="0">
+                <a:solidFill>
+                  <a:srgbClr val="595959"/>
+                </a:solidFill>
+                <a:latin typeface="Segoe UI" pitchFamily="34" charset="0"/>
+                <a:ea typeface="Segoe UI" pitchFamily="34" charset="-122"/>
+                <a:cs typeface="Segoe UI" pitchFamily="34" charset="-120"/>
+              </a:rPr>
+              <a:t>• +1.71 min vs the winter baseline — high volume × slow cycle = peak cost-to-serve.</a:t>
+            </a:r>
+            <a:endParaRPr lang="en-US" sz="1200" dirty="0"/>
+          </a:p>
+          <a:p>
+            <a:pPr indent="0" marL="0">
+              <a:buNone/>
+            </a:pPr>
+            <a:endParaRPr lang="en-US" sz="1200" dirty="0"/>
+          </a:p>
+          <a:p>
+            <a:pPr indent="0" marL="0">
+              <a:buNone/>
+            </a:pPr>
+            <a:r>
+              <a:rPr lang="en-US" sz="1200" dirty="0">
+                <a:solidFill>
+                  <a:srgbClr val="595959"/>
+                </a:solidFill>
+                <a:latin typeface="Segoe UI" pitchFamily="34" charset="0"/>
+                <a:ea typeface="Segoe UI" pitchFamily="34" charset="-122"/>
+                <a:cs typeface="Segoe UI" pitchFamily="34" charset="-120"/>
+              </a:rPr>
+              <a:t>• Spring is the true volume peak (113k trips/day) but operationally efficient (17.44 min).</a:t>
+            </a:r>
+            <a:endParaRPr lang="en-US" sz="1200" dirty="0"/>
+          </a:p>
+          <a:p>
+            <a:pPr indent="0" marL="0">
+              <a:buNone/>
+            </a:pPr>
+            <a:endParaRPr lang="en-US" sz="1200" dirty="0"/>
+          </a:p>
+          <a:p>
+            <a:pPr indent="0" marL="0">
+              <a:buNone/>
+            </a:pPr>
+            <a:r>
+              <a:rPr lang="en-US" sz="1200" dirty="0">
+                <a:solidFill>
+                  <a:srgbClr val="595959"/>
+                </a:solidFill>
+                <a:latin typeface="Segoe UI" pitchFamily="34" charset="0"/>
+                <a:ea typeface="Segoe UI" pitchFamily="34" charset="-122"/>
+                <a:cs typeface="Segoe UI" pitchFamily="34" charset="-120"/>
+              </a:rPr>
+              <a:t>• Winter = low demand + fastest cycle (16.75 min) → maintenance &amp; capacity window.</a:t>
+            </a:r>
+            <a:endParaRPr lang="en-US" sz="1200" dirty="0"/>
+          </a:p>
+        </p:txBody>
+      </p:sp>
+      <p:sp>
+        <p:nvSpPr>
+          <p:cNvPr id="8" name="Shape 6"/>
+          <p:cNvSpPr/>
+          <p:nvPr/>
+        </p:nvSpPr>
+        <p:spPr>
+          <a:xfrm>
+            <a:off x="6309360" y="1691640"/>
+            <a:ext cx="5303520" cy="4023360"/>
+          </a:xfrm>
+          <a:prstGeom prst="rect">
+            <a:avLst/>
+          </a:prstGeom>
+          <a:solidFill>
+            <a:srgbClr val="FFFFFF"/>
+          </a:solidFill>
+          <a:ln w="12700">
+            <a:solidFill>
+              <a:srgbClr val="E0E0E0"/>
+            </a:solidFill>
+            <a:prstDash val="solid"/>
+          </a:ln>
+          <a:effectLst>
+            <a:outerShdw sx="100000" sy="100000" kx="0" ky="0" algn="bl" rotWithShape="0" blurRad="101600" dist="38100" dir="8100000">
+              <a:srgbClr val="1F3864">
+                <a:alpha val="16000"/>
+              </a:srgbClr>
+            </a:outerShdw>
+          </a:effectLst>
+        </p:spPr>
+      </p:sp>
+      <p:sp>
+        <p:nvSpPr>
+          <p:cNvPr id="9" name="Shape 7"/>
+          <p:cNvSpPr/>
+          <p:nvPr/>
+        </p:nvSpPr>
+        <p:spPr>
+          <a:xfrm>
+            <a:off x="6309360" y="1691640"/>
+            <a:ext cx="82296" cy="4023360"/>
+          </a:xfrm>
+          <a:prstGeom prst="rect">
+            <a:avLst/>
+          </a:prstGeom>
+          <a:solidFill>
+            <a:srgbClr val="22A06B"/>
+          </a:solidFill>
+          <a:ln/>
+        </p:spPr>
+      </p:sp>
+      <p:sp>
+        <p:nvSpPr>
+          <p:cNvPr id="10" name="Text 8"/>
+          <p:cNvSpPr/>
+          <p:nvPr/>
+        </p:nvSpPr>
+        <p:spPr>
+          <a:xfrm>
+            <a:off x="6537960" y="1837944"/>
+            <a:ext cx="4937760" cy="320040"/>
+          </a:xfrm>
+          <a:prstGeom prst="rect">
+            <a:avLst/>
+          </a:prstGeom>
+          <a:noFill/>
+          <a:ln/>
+        </p:spPr>
+        <p:txBody>
+          <a:bodyPr wrap="square" lIns="0" tIns="0" rIns="0" bIns="0" rtlCol="0" anchor="ctr"/>
+          <a:lstStyle/>
+          <a:p>
+            <a:pPr indent="0" marL="0">
+              <a:buNone/>
+            </a:pPr>
+            <a:r>
+              <a:rPr lang="en-US" sz="1450" b="1" dirty="0">
+                <a:solidFill>
+                  <a:srgbClr val="1F3864"/>
+                </a:solidFill>
+                <a:latin typeface="Segoe UI Semibold" pitchFamily="34" charset="0"/>
+                <a:ea typeface="Segoe UI Semibold" pitchFamily="34" charset="-122"/>
+                <a:cs typeface="Segoe UI Semibold" pitchFamily="34" charset="-120"/>
+              </a:rPr>
+              <a:t>Page 6 — Extreme weather</a:t>
+            </a:r>
+            <a:endParaRPr lang="en-US" sz="1450" dirty="0"/>
+          </a:p>
+        </p:txBody>
+      </p:sp>
+      <p:sp>
+        <p:nvSpPr>
+          <p:cNvPr id="11" name="Text 9"/>
+          <p:cNvSpPr/>
+          <p:nvPr/>
+        </p:nvSpPr>
+        <p:spPr>
+          <a:xfrm>
+            <a:off x="6537960" y="2203704"/>
+            <a:ext cx="4937760" cy="3383280"/>
+          </a:xfrm>
+          <a:prstGeom prst="rect">
+            <a:avLst/>
+          </a:prstGeom>
+          <a:noFill/>
+          <a:ln/>
+        </p:spPr>
+        <p:txBody>
+          <a:bodyPr wrap="square" lIns="0" tIns="0" rIns="0" bIns="0" rtlCol="0" anchor="t"/>
+          <a:lstStyle/>
+          <a:p>
+            <a:pPr indent="0" marL="0">
+              <a:buNone/>
+            </a:pPr>
+            <a:r>
+              <a:rPr lang="en-US" sz="1200" dirty="0">
+                <a:solidFill>
+                  <a:srgbClr val="595959"/>
+                </a:solidFill>
+                <a:latin typeface="Segoe UI" pitchFamily="34" charset="0"/>
+                <a:ea typeface="Segoe UI" pitchFamily="34" charset="-122"/>
+                <a:cs typeface="Segoe UI" pitchFamily="34" charset="-120"/>
+              </a:rPr>
+              <a:t>Do external shocks change the operation?</a:t>
+            </a:r>
+            <a:endParaRPr lang="en-US" sz="1200" dirty="0"/>
+          </a:p>
+          <a:p>
+            <a:pPr indent="0" marL="0">
+              <a:buNone/>
+            </a:pPr>
+            <a:endParaRPr lang="en-US" sz="1200" dirty="0"/>
+          </a:p>
+          <a:p>
+            <a:pPr indent="0" marL="0">
+              <a:buNone/>
+            </a:pPr>
+            <a:r>
+              <a:rPr lang="en-US" sz="1200" dirty="0">
+                <a:solidFill>
+                  <a:srgbClr val="595959"/>
+                </a:solidFill>
+                <a:latin typeface="Segoe UI" pitchFamily="34" charset="0"/>
+                <a:ea typeface="Segoe UI" pitchFamily="34" charset="-122"/>
+                <a:cs typeface="Segoe UI" pitchFamily="34" charset="-120"/>
+              </a:rPr>
+              <a:t>• Only 4 extreme days in 1,096 — but demand drops 36% (106k → 68k trips/day).</a:t>
+            </a:r>
+            <a:endParaRPr lang="en-US" sz="1200" dirty="0"/>
+          </a:p>
+          <a:p>
+            <a:pPr indent="0" marL="0">
+              <a:buNone/>
+            </a:pPr>
+            <a:endParaRPr lang="en-US" sz="1200" dirty="0"/>
+          </a:p>
+          <a:p>
+            <a:pPr indent="0" marL="0">
+              <a:buNone/>
+            </a:pPr>
+            <a:r>
+              <a:rPr lang="en-US" sz="1200" dirty="0">
+                <a:solidFill>
+                  <a:srgbClr val="595959"/>
+                </a:solidFill>
+                <a:latin typeface="Segoe UI" pitchFamily="34" charset="0"/>
+                <a:ea typeface="Segoe UI" pitchFamily="34" charset="-122"/>
+                <a:cs typeface="Segoe UI" pitchFamily="34" charset="-120"/>
+              </a:rPr>
+              <a:t>• Counter-intuitively, lead time gets ~3.8 min faster and the average fare falls.</a:t>
+            </a:r>
+            <a:endParaRPr lang="en-US" sz="1200" dirty="0"/>
+          </a:p>
+          <a:p>
+            <a:pPr indent="0" marL="0">
+              <a:buNone/>
+            </a:pPr>
+            <a:endParaRPr lang="en-US" sz="1200" dirty="0"/>
+          </a:p>
+          <a:p>
+            <a:pPr indent="0" marL="0">
+              <a:buNone/>
+            </a:pPr>
+            <a:r>
+              <a:rPr lang="en-US" sz="1200" dirty="0">
+                <a:solidFill>
+                  <a:srgbClr val="595959"/>
+                </a:solidFill>
+                <a:latin typeface="Segoe UI" pitchFamily="34" charset="0"/>
+                <a:ea typeface="Segoe UI" pitchFamily="34" charset="-122"/>
+                <a:cs typeface="Segoe UI" pitchFamily="34" charset="-120"/>
+              </a:rPr>
+              <a:t>• Demand self-selection: only the essential trips remain, and with less traffic the cycle shortens.</a:t>
+            </a:r>
+            <a:endParaRPr lang="en-US" sz="1200" dirty="0"/>
+          </a:p>
+          <a:p>
+            <a:pPr indent="0" marL="0">
+              <a:buNone/>
+            </a:pPr>
+            <a:endParaRPr lang="en-US" sz="1200" dirty="0"/>
+          </a:p>
+          <a:p>
+            <a:pPr indent="0" marL="0">
+              <a:buNone/>
+            </a:pPr>
+            <a:r>
+              <a:rPr lang="en-US" sz="1200" dirty="0">
+                <a:solidFill>
+                  <a:srgbClr val="595959"/>
+                </a:solidFill>
+                <a:latin typeface="Segoe UI" pitchFamily="34" charset="0"/>
+                <a:ea typeface="Segoe UI" pitchFamily="34" charset="-122"/>
+                <a:cs typeface="Segoe UI" pitchFamily="34" charset="-120"/>
+              </a:rPr>
+              <a:t>Supply-chain parallel: a disruption that cuts volume but reshapes the network.</a:t>
+            </a:r>
+            <a:endParaRPr lang="en-US" sz="1200" dirty="0"/>
+          </a:p>
+        </p:txBody>
+      </p:sp>
+      <p:sp>
+        <p:nvSpPr>
+          <p:cNvPr id="12" name="Text 10"/>
+          <p:cNvSpPr/>
+          <p:nvPr/>
+        </p:nvSpPr>
+        <p:spPr>
+          <a:xfrm>
+            <a:off x="548640" y="6455664"/>
+            <a:ext cx="7315200" cy="274320"/>
+          </a:xfrm>
+          <a:prstGeom prst="rect">
+            <a:avLst/>
+          </a:prstGeom>
+          <a:noFill/>
+          <a:ln/>
+        </p:spPr>
+        <p:txBody>
+          <a:bodyPr wrap="square" lIns="0" tIns="0" rIns="0" bIns="0" rtlCol="0" anchor="ctr"/>
+          <a:lstStyle/>
+          <a:p>
+            <a:pPr indent="0" marL="0">
+              <a:buNone/>
+            </a:pPr>
+            <a:r>
+              <a:rPr lang="en-US" sz="900" dirty="0">
+                <a:solidFill>
+                  <a:srgbClr val="808080"/>
+                </a:solidFill>
+                <a:latin typeface="Segoe UI" pitchFamily="34" charset="0"/>
+                <a:ea typeface="Segoe UI" pitchFamily="34" charset="-122"/>
+                <a:cs typeface="Segoe UI" pitchFamily="34" charset="-120"/>
+              </a:rPr>
+              <a:t>NYC TLC Yellow Taxi  ·  3M Technical Case</a:t>
+            </a:r>
+            <a:endParaRPr lang="en-US" sz="900" dirty="0"/>
+          </a:p>
+        </p:txBody>
+      </p:sp>
+      <p:sp>
+        <p:nvSpPr>
+          <p:cNvPr id="13" name="Text 11"/>
+          <p:cNvSpPr/>
+          <p:nvPr/>
+        </p:nvSpPr>
+        <p:spPr>
+          <a:xfrm>
+            <a:off x="11430000" y="6455664"/>
+            <a:ext cx="365760" cy="274320"/>
+          </a:xfrm>
+          <a:prstGeom prst="rect">
+            <a:avLst/>
+          </a:prstGeom>
+          <a:noFill/>
+          <a:ln/>
+        </p:spPr>
+        <p:txBody>
+          <a:bodyPr wrap="square" lIns="0" tIns="0" rIns="0" bIns="0" rtlCol="0" anchor="ctr"/>
+          <a:lstStyle/>
+          <a:p>
+            <a:pPr algn="r" indent="0" marL="0">
+              <a:buNone/>
+            </a:pPr>
+            <a:r>
+              <a:rPr lang="en-US" sz="900" dirty="0">
+                <a:solidFill>
+                  <a:srgbClr val="808080"/>
+                </a:solidFill>
+                <a:latin typeface="Segoe UI" pitchFamily="34" charset="0"/>
+                <a:ea typeface="Segoe UI" pitchFamily="34" charset="-122"/>
+                <a:cs typeface="Segoe UI" pitchFamily="34" charset="-120"/>
+              </a:rPr>
+              <a:t>13</a:t>
+            </a:r>
+            <a:endParaRPr lang="en-US" sz="900" dirty="0"/>
           </a:p>
         </p:txBody>
       </p:sp>
@@ -9025,7 +9658,7 @@
                 <a:ea typeface="Segoe UI" pitchFamily="34" charset="-122"/>
                 <a:cs typeface="Segoe UI" pitchFamily="34" charset="-120"/>
               </a:rPr>
-              <a:t>Medallion architecture  </a:t>
+              <a:t xml:space="preserve">Medallion architecture  </a:t>
             </a:r>
             <a:pPr indent="0" marL="0">
               <a:buNone/>
@@ -9078,7 +9711,7 @@
                 <a:ea typeface="Segoe UI" pitchFamily="34" charset="-122"/>
                 <a:cs typeface="Segoe UI" pitchFamily="34" charset="-120"/>
               </a:rPr>
-              <a:t>The 5 pipeline blocks the briefing asked to discuss: </a:t>
+              <a:t xml:space="preserve">The 5 pipeline blocks the briefing asked to discuss: </a:t>
             </a:r>
             <a:pPr indent="0" marL="0">
               <a:buNone/>

</xml_diff>